<commit_message>
0.1.0-beta.5: add Paper style, restore Showship signature
</commit_message>
<xml_diff>
--- a/docs/example-deck-showship.pptx
+++ b/docs/example-deck-showship.pptx
@@ -2271,7 +2271,7 @@
       </p:grpSpPr>
       <p:pic>
         <p:nvPicPr>
-          <p:cNvPr id="2" name="Image 0" descr="/sessions/beautiful-vigilant-darwin/tmp/showship-deck-zktDWi/trail_bookend.png">    </p:cNvPr>
+          <p:cNvPr id="2" name="Image 0" descr="/sessions/beautiful-vigilant-darwin/tmp/showship-deck-1uRcfa/trail_bookend.png">    </p:cNvPr>
           <p:cNvPicPr>
             <a:picLocks noChangeAspect="1"/>
           </p:cNvPicPr>
@@ -2295,7 +2295,7 @@
       </p:pic>
       <p:pic>
         <p:nvPicPr>
-          <p:cNvPr id="3" name="Image 1" descr="/sessions/beautiful-vigilant-darwin/tmp/showship-deck-zktDWi/logo_trimmed.png">    </p:cNvPr>
+          <p:cNvPr id="3" name="Image 1" descr="/sessions/beautiful-vigilant-darwin/tmp/showship-deck-1uRcfa/logo_trimmed.png">    </p:cNvPr>
           <p:cNvPicPr>
             <a:picLocks noChangeAspect="1"/>
           </p:cNvPicPr>
@@ -2627,7 +2627,7 @@
       </p:sp>
       <p:pic>
         <p:nvPicPr>
-          <p:cNvPr id="11" name="Image 2" descr="/sessions/beautiful-vigilant-darwin/tmp/showship-deck-zktDWi/trail_mark.png">    </p:cNvPr>
+          <p:cNvPr id="11" name="Image 2" descr="/sessions/beautiful-vigilant-darwin/tmp/showship-deck-1uRcfa/trail_mark.png">    </p:cNvPr>
           <p:cNvPicPr>
             <a:picLocks noChangeAspect="1"/>
           </p:cNvPicPr>
@@ -2736,7 +2736,7 @@
       </p:grpSpPr>
       <p:pic>
         <p:nvPicPr>
-          <p:cNvPr id="2" name="Image 0" descr="/sessions/beautiful-vigilant-darwin/tmp/showship-deck-zktDWi/trail_corner.png">    </p:cNvPr>
+          <p:cNvPr id="2" name="Image 0" descr="/sessions/beautiful-vigilant-darwin/tmp/showship-deck-1uRcfa/trail_corner.png">    </p:cNvPr>
           <p:cNvPicPr>
             <a:picLocks noChangeAspect="1"/>
           </p:cNvPicPr>
@@ -2860,7 +2860,7 @@
       </p:sp>
       <p:pic>
         <p:nvPicPr>
-          <p:cNvPr id="6" name="Image 1" descr="/sessions/beautiful-vigilant-darwin/tmp/showship-deck-zktDWi/trail_mark.png">    </p:cNvPr>
+          <p:cNvPr id="6" name="Image 1" descr="/sessions/beautiful-vigilant-darwin/tmp/showship-deck-1uRcfa/trail_mark.png">    </p:cNvPr>
           <p:cNvPicPr>
             <a:picLocks noChangeAspect="1"/>
           </p:cNvPicPr>
@@ -4360,7 +4360,7 @@
       </p:grpSpPr>
       <p:pic>
         <p:nvPicPr>
-          <p:cNvPr id="2" name="Image 0" descr="/sessions/beautiful-vigilant-darwin/tmp/showship-deck-zktDWi/trail_bookend.png">    </p:cNvPr>
+          <p:cNvPr id="2" name="Image 0" descr="/sessions/beautiful-vigilant-darwin/tmp/showship-deck-1uRcfa/trail_bookend.png">    </p:cNvPr>
           <p:cNvPicPr>
             <a:picLocks noChangeAspect="1"/>
           </p:cNvPicPr>
@@ -4384,7 +4384,7 @@
       </p:pic>
       <p:pic>
         <p:nvPicPr>
-          <p:cNvPr id="3" name="Image 1" descr="/sessions/beautiful-vigilant-darwin/tmp/showship-deck-zktDWi/logo_trimmed.png">    </p:cNvPr>
+          <p:cNvPr id="3" name="Image 1" descr="/sessions/beautiful-vigilant-darwin/tmp/showship-deck-1uRcfa/logo_trimmed.png">    </p:cNvPr>
           <p:cNvPicPr>
             <a:picLocks noChangeAspect="1"/>
           </p:cNvPicPr>
@@ -4693,7 +4693,7 @@
       </p:sp>
       <p:pic>
         <p:nvPicPr>
-          <p:cNvPr id="11" name="Image 2" descr="/sessions/beautiful-vigilant-darwin/tmp/showship-deck-zktDWi/trail_mark.png">    </p:cNvPr>
+          <p:cNvPr id="11" name="Image 2" descr="/sessions/beautiful-vigilant-darwin/tmp/showship-deck-1uRcfa/trail_mark.png">    </p:cNvPr>
           <p:cNvPicPr>
             <a:picLocks noChangeAspect="1"/>
           </p:cNvPicPr>
@@ -4802,7 +4802,7 @@
       </p:grpSpPr>
       <p:pic>
         <p:nvPicPr>
-          <p:cNvPr id="2" name="Image 0" descr="/sessions/beautiful-vigilant-darwin/tmp/showship-deck-zktDWi/trail_corner.png">    </p:cNvPr>
+          <p:cNvPr id="2" name="Image 0" descr="/sessions/beautiful-vigilant-darwin/tmp/showship-deck-1uRcfa/trail_corner.png">    </p:cNvPr>
           <p:cNvPicPr>
             <a:picLocks noChangeAspect="1"/>
           </p:cNvPicPr>
@@ -4926,7 +4926,7 @@
       </p:sp>
       <p:pic>
         <p:nvPicPr>
-          <p:cNvPr id="6" name="Image 1" descr="/sessions/beautiful-vigilant-darwin/tmp/showship-deck-zktDWi/trail_mark.png">    </p:cNvPr>
+          <p:cNvPr id="6" name="Image 1" descr="/sessions/beautiful-vigilant-darwin/tmp/showship-deck-1uRcfa/trail_mark.png">    </p:cNvPr>
           <p:cNvPicPr>
             <a:picLocks noChangeAspect="1"/>
           </p:cNvPicPr>
@@ -6244,7 +6244,7 @@
       </p:grpSpPr>
       <p:pic>
         <p:nvPicPr>
-          <p:cNvPr id="2" name="Image 0" descr="/sessions/beautiful-vigilant-darwin/tmp/showship-deck-zktDWi/trail_corner.png">    </p:cNvPr>
+          <p:cNvPr id="2" name="Image 0" descr="/sessions/beautiful-vigilant-darwin/tmp/showship-deck-1uRcfa/trail_corner.png">    </p:cNvPr>
           <p:cNvPicPr>
             <a:picLocks noChangeAspect="1"/>
           </p:cNvPicPr>
@@ -6368,7 +6368,7 @@
       </p:sp>
       <p:pic>
         <p:nvPicPr>
-          <p:cNvPr id="6" name="Image 1" descr="/sessions/beautiful-vigilant-darwin/tmp/showship-deck-zktDWi/trail_mark.png">    </p:cNvPr>
+          <p:cNvPr id="6" name="Image 1" descr="/sessions/beautiful-vigilant-darwin/tmp/showship-deck-1uRcfa/trail_mark.png">    </p:cNvPr>
           <p:cNvPicPr>
             <a:picLocks noChangeAspect="1"/>
           </p:cNvPicPr>
@@ -6545,7 +6545,7 @@
       </p:sp>
       <p:pic>
         <p:nvPicPr>
-          <p:cNvPr id="11" name="Image 2" descr="/sessions/beautiful-vigilant-darwin/tmp/showship-deck-zktDWi/trail_tl_1.png">    </p:cNvPr>
+          <p:cNvPr id="11" name="Image 2" descr="/sessions/beautiful-vigilant-darwin/tmp/showship-deck-1uRcfa/trail_tl_1.png">    </p:cNvPr>
           <p:cNvPicPr>
             <a:picLocks noChangeAspect="1"/>
           </p:cNvPicPr>
@@ -7505,7 +7505,7 @@
       </p:grpSpPr>
       <p:pic>
         <p:nvPicPr>
-          <p:cNvPr id="2" name="Image 0" descr="/sessions/beautiful-vigilant-darwin/tmp/showship-deck-zktDWi/trail_corner.png">    </p:cNvPr>
+          <p:cNvPr id="2" name="Image 0" descr="/sessions/beautiful-vigilant-darwin/tmp/showship-deck-1uRcfa/trail_corner.png">    </p:cNvPr>
           <p:cNvPicPr>
             <a:picLocks noChangeAspect="1"/>
           </p:cNvPicPr>
@@ -7629,7 +7629,7 @@
       </p:sp>
       <p:pic>
         <p:nvPicPr>
-          <p:cNvPr id="6" name="Image 1" descr="/sessions/beautiful-vigilant-darwin/tmp/showship-deck-zktDWi/trail_mark.png">    </p:cNvPr>
+          <p:cNvPr id="6" name="Image 1" descr="/sessions/beautiful-vigilant-darwin/tmp/showship-deck-1uRcfa/trail_mark.png">    </p:cNvPr>
           <p:cNvPicPr>
             <a:picLocks noChangeAspect="1"/>
           </p:cNvPicPr>
@@ -8903,7 +8903,7 @@
       </p:grpSpPr>
       <p:pic>
         <p:nvPicPr>
-          <p:cNvPr id="2" name="Image 0" descr="/sessions/beautiful-vigilant-darwin/tmp/showship-deck-zktDWi/trail_corner.png">    </p:cNvPr>
+          <p:cNvPr id="2" name="Image 0" descr="/sessions/beautiful-vigilant-darwin/tmp/showship-deck-1uRcfa/trail_corner.png">    </p:cNvPr>
           <p:cNvPicPr>
             <a:picLocks noChangeAspect="1"/>
           </p:cNvPicPr>
@@ -9027,7 +9027,7 @@
       </p:sp>
       <p:pic>
         <p:nvPicPr>
-          <p:cNvPr id="6" name="Image 1" descr="/sessions/beautiful-vigilant-darwin/tmp/showship-deck-zktDWi/trail_mark.png">    </p:cNvPr>
+          <p:cNvPr id="6" name="Image 1" descr="/sessions/beautiful-vigilant-darwin/tmp/showship-deck-1uRcfa/trail_mark.png">    </p:cNvPr>
           <p:cNvPicPr>
             <a:picLocks noChangeAspect="1"/>
           </p:cNvPicPr>
@@ -10567,7 +10567,7 @@
       </p:grpSpPr>
       <p:pic>
         <p:nvPicPr>
-          <p:cNvPr id="2" name="Image 0" descr="/sessions/beautiful-vigilant-darwin/tmp/showship-deck-zktDWi/trail_corner.png">    </p:cNvPr>
+          <p:cNvPr id="2" name="Image 0" descr="/sessions/beautiful-vigilant-darwin/tmp/showship-deck-1uRcfa/trail_corner.png">    </p:cNvPr>
           <p:cNvPicPr>
             <a:picLocks noChangeAspect="1"/>
           </p:cNvPicPr>
@@ -10691,7 +10691,7 @@
       </p:sp>
       <p:pic>
         <p:nvPicPr>
-          <p:cNvPr id="6" name="Image 1" descr="/sessions/beautiful-vigilant-darwin/tmp/showship-deck-zktDWi/trail_mark.png">    </p:cNvPr>
+          <p:cNvPr id="6" name="Image 1" descr="/sessions/beautiful-vigilant-darwin/tmp/showship-deck-1uRcfa/trail_mark.png">    </p:cNvPr>
           <p:cNvPicPr>
             <a:picLocks noChangeAspect="1"/>
           </p:cNvPicPr>
@@ -11183,7 +11183,7 @@
       </p:sp>
       <p:pic>
         <p:nvPicPr>
-          <p:cNvPr id="20" name="Image 2" descr="/sessions/beautiful-vigilant-darwin/tmp/showship-deck-zktDWi/iconc_Check_FFFFFF.png">    </p:cNvPr>
+          <p:cNvPr id="20" name="Image 2" descr="/sessions/beautiful-vigilant-darwin/tmp/showship-deck-1uRcfa/iconc_Check_FFFFFF.png">    </p:cNvPr>
           <p:cNvPicPr>
             <a:picLocks noChangeAspect="1"/>
           </p:cNvPicPr>
@@ -11405,7 +11405,7 @@
       </p:sp>
       <p:pic>
         <p:nvPicPr>
-          <p:cNvPr id="27" name="Image 3" descr="/sessions/beautiful-vigilant-darwin/tmp/showship-deck-zktDWi/iconc_Wrench_FFFFFF.png">    </p:cNvPr>
+          <p:cNvPr id="27" name="Image 3" descr="/sessions/beautiful-vigilant-darwin/tmp/showship-deck-1uRcfa/iconc_Wrench_FFFFFF.png">    </p:cNvPr>
           <p:cNvPicPr>
             <a:picLocks noChangeAspect="1"/>
           </p:cNvPicPr>
@@ -11627,7 +11627,7 @@
       </p:sp>
       <p:pic>
         <p:nvPicPr>
-          <p:cNvPr id="34" name="Image 4" descr="/sessions/beautiful-vigilant-darwin/tmp/showship-deck-zktDWi/iconc_Check_FFFFFF.png">    </p:cNvPr>
+          <p:cNvPr id="34" name="Image 4" descr="/sessions/beautiful-vigilant-darwin/tmp/showship-deck-1uRcfa/iconc_Check_FFFFFF.png">    </p:cNvPr>
           <p:cNvPicPr>
             <a:picLocks noChangeAspect="1"/>
           </p:cNvPicPr>
@@ -11866,7 +11866,7 @@
       </p:grpSpPr>
       <p:pic>
         <p:nvPicPr>
-          <p:cNvPr id="2" name="Image 0" descr="/sessions/beautiful-vigilant-darwin/tmp/showship-deck-zktDWi/trail_corner.png">    </p:cNvPr>
+          <p:cNvPr id="2" name="Image 0" descr="/sessions/beautiful-vigilant-darwin/tmp/showship-deck-1uRcfa/trail_corner.png">    </p:cNvPr>
           <p:cNvPicPr>
             <a:picLocks noChangeAspect="1"/>
           </p:cNvPicPr>
@@ -11990,7 +11990,7 @@
       </p:sp>
       <p:pic>
         <p:nvPicPr>
-          <p:cNvPr id="6" name="Image 1" descr="/sessions/beautiful-vigilant-darwin/tmp/showship-deck-zktDWi/trail_mark.png">    </p:cNvPr>
+          <p:cNvPr id="6" name="Image 1" descr="/sessions/beautiful-vigilant-darwin/tmp/showship-deck-1uRcfa/trail_mark.png">    </p:cNvPr>
           <p:cNvPicPr>
             <a:picLocks noChangeAspect="1"/>
           </p:cNvPicPr>
@@ -12182,7 +12182,7 @@
       </p:sp>
       <p:pic>
         <p:nvPicPr>
-          <p:cNvPr id="12" name="Image 2" descr="/sessions/beautiful-vigilant-darwin/tmp/showship-deck-zktDWi/iconc_TriangleAlert_FFFFFF.png">    </p:cNvPr>
+          <p:cNvPr id="12" name="Image 2" descr="/sessions/beautiful-vigilant-darwin/tmp/showship-deck-1uRcfa/iconc_TriangleAlert_FFFFFF.png">    </p:cNvPr>
           <p:cNvPicPr>
             <a:picLocks noChangeAspect="1"/>
           </p:cNvPicPr>
@@ -12512,7 +12512,7 @@
       </p:sp>
       <p:pic>
         <p:nvPicPr>
-          <p:cNvPr id="21" name="Image 3" descr="/sessions/beautiful-vigilant-darwin/tmp/showship-deck-zktDWi/iconc_MessageCircleQuestion_FFFFFF.png">    </p:cNvPr>
+          <p:cNvPr id="21" name="Image 3" descr="/sessions/beautiful-vigilant-darwin/tmp/showship-deck-1uRcfa/iconc_MessageCircleQuestion_FFFFFF.png">    </p:cNvPr>
           <p:cNvPicPr>
             <a:picLocks noChangeAspect="1"/>
           </p:cNvPicPr>
@@ -12798,7 +12798,7 @@
       </p:grpSpPr>
       <p:pic>
         <p:nvPicPr>
-          <p:cNvPr id="2" name="Image 0" descr="/sessions/beautiful-vigilant-darwin/tmp/showship-deck-zktDWi/trail_corner.png">    </p:cNvPr>
+          <p:cNvPr id="2" name="Image 0" descr="/sessions/beautiful-vigilant-darwin/tmp/showship-deck-1uRcfa/trail_corner.png">    </p:cNvPr>
           <p:cNvPicPr>
             <a:picLocks noChangeAspect="1"/>
           </p:cNvPicPr>
@@ -12922,7 +12922,7 @@
       </p:sp>
       <p:pic>
         <p:nvPicPr>
-          <p:cNvPr id="6" name="Image 1" descr="/sessions/beautiful-vigilant-darwin/tmp/showship-deck-zktDWi/trail_mark.png">    </p:cNvPr>
+          <p:cNvPr id="6" name="Image 1" descr="/sessions/beautiful-vigilant-darwin/tmp/showship-deck-1uRcfa/trail_mark.png">    </p:cNvPr>
           <p:cNvPicPr>
             <a:picLocks noChangeAspect="1"/>
           </p:cNvPicPr>
@@ -14442,7 +14442,7 @@
                 <a:ea typeface="Poppins" pitchFamily="34" charset="-122"/>
                 <a:cs typeface="Poppins" pitchFamily="34" charset="-120"/>
               </a:rPr>
-              <a:t>P4 · Reminders — in review (5/5)</a:t>
+              <a:t>P4 · Reminders, in review (5/5)</a:t>
             </a:r>
             <a:endParaRPr lang="en-US" sz="1000" dirty="0"/>
           </a:p>
@@ -15343,7 +15343,7 @@
       </p:grpSpPr>
       <p:pic>
         <p:nvPicPr>
-          <p:cNvPr id="2" name="Image 0" descr="/sessions/beautiful-vigilant-darwin/tmp/showship-deck-zktDWi/trail_corner.png">    </p:cNvPr>
+          <p:cNvPr id="2" name="Image 0" descr="/sessions/beautiful-vigilant-darwin/tmp/showship-deck-1uRcfa/trail_corner.png">    </p:cNvPr>
           <p:cNvPicPr>
             <a:picLocks noChangeAspect="1"/>
           </p:cNvPicPr>
@@ -15467,7 +15467,7 @@
       </p:sp>
       <p:pic>
         <p:nvPicPr>
-          <p:cNvPr id="6" name="Image 1" descr="/sessions/beautiful-vigilant-darwin/tmp/showship-deck-zktDWi/trail_mark.png">    </p:cNvPr>
+          <p:cNvPr id="6" name="Image 1" descr="/sessions/beautiful-vigilant-darwin/tmp/showship-deck-1uRcfa/trail_mark.png">    </p:cNvPr>
           <p:cNvPicPr>
             <a:picLocks noChangeAspect="1"/>
           </p:cNvPicPr>

</xml_diff>